<commit_message>
Update project analysis and Brief C deliverables
</commit_message>
<xml_diff>
--- a/slides/Group10_Brief_C.pptx
+++ b/slides/Group10_Brief_C.pptx
@@ -4196,7 +4196,7 @@
                 </a:solidFill>
                 <a:latin typeface="Aptos"/>
               </a:rPr>
-              <a:t>At 15 July: ₹1.648 crore remains open across 9,824 H1 invoices (6.14% of H1 billings).</a:t>
+              <a:t>Volume growth: 5% actual; 18% plan-estimated. At 15 July, ₹1.648 crore remained open across 9,824 H1 invoices.</a:t>
             </a:r>
           </a:p>
         </p:txBody>
@@ -8102,7 +8102,7 @@
                 </a:solidFill>
                 <a:latin typeface="Aptos"/>
               </a:rPr>
-              <a:t>DO FIRST  ·  Review June invoices: ₹0.755 crore remained open by 15 July, 45.8% of the total open balance.</a:t>
+              <a:t>DO FIRST  ·  June at H1 close: ₹1.053 crore across 6,256 invoices (54.1% of close balance); ₹0.755 crore remained at 15 July.</a:t>
             </a:r>
           </a:p>
           <a:p>
@@ -8131,7 +8131,7 @@
                 </a:solidFill>
                 <a:latin typeface="Aptos"/>
               </a:rPr>
-              <a:t>THEN  ·  Investigate 1,541 unmatched H1 captured attempts (₹0.267 crore), preserving raw references and source rows.</a:t>
+              <a:t>THEN  ·  Reconcile 1,541 unmatched captures (₹26.68 lakh), led by UPI (792 / ₹13.76 lakh); review reference variants.</a:t>
             </a:r>
           </a:p>
           <a:p>
@@ -8160,7 +8160,7 @@
                 </a:solidFill>
                 <a:latin typeface="Aptos"/>
               </a:rPr>
-              <a:t>EFFORT  ·  Finance + billing + gateway owners: validate IDs, capture cutoffs, refunds, cash and settlement batches. Cost and staffing not estimated in source.</a:t>
+              <a:t>EFFORT  ·  H1-close city balances (₹ lakh): Bengaluru 46.32; Ahmedabad 36.55; Chennai 33.39; Hyderabad 33.07; Pune 28.28; Jaipur 17.04. Compare with billed value before ranking.</a:t>
             </a:r>
           </a:p>
           <a:p>

</xml_diff>